<commit_message>
fixed up to 11 anova need to finish activity and non parametric
</commit_message>
<xml_diff>
--- a/docs/ecostats_lectures/lecture_10/10_01_lecture_powerpoint.pptx
+++ b/docs/ecostats_lectures/lecture_10/10_01_lecture_powerpoint.pptx
@@ -7311,7 +7311,15 @@
             <a:pPr lvl="0"/>
             <a:r>
               <a:rPr/>
-              <a:t>2n is required; 6 parameters= 64 terms; 7 parameters= 128</a:t>
+              <a:t>2</a:t>
+            </a:r>
+            <a:r>
+              <a:rPr baseline="30000"/>
+              <a:t>n</a:t>
+            </a:r>
+            <a:r>
+              <a:rPr/>
+              <a:t> is required; 6 parameters = 64 terms; 7 parameters= 128</a:t>
             </a:r>
           </a:p>
           <a:p>

</xml_diff>